<commit_message>
Add second author (Punith VC) to paper and slides
Co-Authored-By: Claude Sonnet 5.5 <noreply@anthropic.com>
Claude-Session: https://claude.ai/code/session_01STSHsvB5pk56wLxDVabF7L
</commit_message>
<xml_diff>
--- a/slides/markov_prefetch_slides.pptx
+++ b/slides/markov_prefetch_slides.pptx
@@ -2603,6 +2603,20 @@
                 </a:solidFill>
               </a:rPr>
               <a:t>Pala Gaurav Reddy  ·  PES1UG25AM254</a:t>
+            </a:r>
+            <a:endParaRPr lang="en-US" sz="1800" dirty="0"/>
+          </a:p>
+          <a:p>
+            <a:pPr algn="l" indent="0" marL="0">
+              <a:buNone/>
+            </a:pPr>
+            <a:r>
+              <a:rPr lang="en-US" sz="1600" dirty="0">
+                <a:solidFill>
+                  <a:schemeClr val="bg1"/>
+                </a:solidFill>
+              </a:rPr>
+              <a:t>Punith VC  ·  PES1UG25AM295</a:t>
             </a:r>
             <a:endParaRPr lang="en-US" sz="1800" dirty="0"/>
           </a:p>

</xml_diff>